<commit_message>
Add Qwen justification generation for positive predictions and update presentation materials
</commit_message>
<xml_diff>
--- a/paper/presentation/ietf_ambiguity_detection_presentation.pptx
+++ b/paper/presentation/ietf_ambiguity_detection_presentation.pptx
@@ -9798,7 +9798,7 @@
         <p:spPr>
           <a:xfrm>
             <a:off x="7132320" y="1371600"/>
-            <a:ext cx="4069080" cy="3611880"/>
+            <a:ext cx="4069080" cy="2331720"/>
           </a:xfrm>
           <a:prstGeom prst="roundRect">
             <a:avLst/>
@@ -9842,7 +9842,7 @@
         </p:nvSpPr>
         <p:spPr>
           <a:xfrm>
-            <a:off x="7452360" y="1700784"/>
+            <a:off x="7452360" y="1627632"/>
             <a:ext cx="3429000" cy="384048"/>
           </a:xfrm>
           <a:prstGeom prst="rect">
@@ -9881,7 +9881,7 @@
         </p:nvSpPr>
         <p:spPr>
           <a:xfrm>
-            <a:off x="7452360" y="2368296"/>
+            <a:off x="7452360" y="2139696"/>
             <a:ext cx="164592" cy="164592"/>
           </a:xfrm>
           <a:prstGeom prst="ellipse">
@@ -9924,7 +9924,7 @@
         </p:nvSpPr>
         <p:spPr>
           <a:xfrm>
-            <a:off x="7452360" y="2372868"/>
+            <a:off x="7452360" y="2144268"/>
             <a:ext cx="164592" cy="155448"/>
           </a:xfrm>
           <a:prstGeom prst="rect">
@@ -9960,8 +9960,8 @@
         </p:nvSpPr>
         <p:spPr>
           <a:xfrm>
-            <a:off x="7744968" y="2331720"/>
-            <a:ext cx="3044952" cy="667512"/>
+            <a:off x="7744968" y="2103120"/>
+            <a:ext cx="3044952" cy="384048"/>
           </a:xfrm>
           <a:prstGeom prst="rect">
             <a:avLst/>
@@ -9978,7 +9978,7 @@
               <a:spcAft>
                 <a:spcPts val="500"/>
               </a:spcAft>
-              <a:defRPr sz="1500" b="0">
+              <a:defRPr sz="1300" b="0">
                 <a:solidFill>
                   <a:srgbClr val="26313B"/>
                 </a:solidFill>
@@ -9999,7 +9999,7 @@
         </p:nvSpPr>
         <p:spPr>
           <a:xfrm>
-            <a:off x="7452360" y="3090672"/>
+            <a:off x="7452360" y="2578608"/>
             <a:ext cx="164592" cy="164592"/>
           </a:xfrm>
           <a:prstGeom prst="ellipse">
@@ -10042,7 +10042,7 @@
         </p:nvSpPr>
         <p:spPr>
           <a:xfrm>
-            <a:off x="7452360" y="3095244"/>
+            <a:off x="7452360" y="2583179"/>
             <a:ext cx="164592" cy="155448"/>
           </a:xfrm>
           <a:prstGeom prst="rect">
@@ -10078,8 +10078,8 @@
         </p:nvSpPr>
         <p:spPr>
           <a:xfrm>
-            <a:off x="7744968" y="3054096"/>
-            <a:ext cx="3044952" cy="667512"/>
+            <a:off x="7744968" y="2542032"/>
+            <a:ext cx="3044952" cy="384048"/>
           </a:xfrm>
           <a:prstGeom prst="rect">
             <a:avLst/>
@@ -10096,7 +10096,7 @@
               <a:spcAft>
                 <a:spcPts val="500"/>
               </a:spcAft>
-              <a:defRPr sz="1500" b="0">
+              <a:defRPr sz="1300" b="0">
                 <a:solidFill>
                   <a:srgbClr val="26313B"/>
                 </a:solidFill>
@@ -10117,7 +10117,7 @@
         </p:nvSpPr>
         <p:spPr>
           <a:xfrm>
-            <a:off x="7452360" y="3813048"/>
+            <a:off x="7452360" y="3017520"/>
             <a:ext cx="164592" cy="164592"/>
           </a:xfrm>
           <a:prstGeom prst="ellipse">
@@ -10160,7 +10160,7 @@
         </p:nvSpPr>
         <p:spPr>
           <a:xfrm>
-            <a:off x="7452360" y="3817620"/>
+            <a:off x="7452360" y="3022091"/>
             <a:ext cx="164592" cy="155448"/>
           </a:xfrm>
           <a:prstGeom prst="rect">
@@ -10196,8 +10196,8 @@
         </p:nvSpPr>
         <p:spPr>
           <a:xfrm>
-            <a:off x="7744968" y="3776472"/>
-            <a:ext cx="3044952" cy="667512"/>
+            <a:off x="7744968" y="2980944"/>
+            <a:ext cx="3044952" cy="384048"/>
           </a:xfrm>
           <a:prstGeom prst="rect">
             <a:avLst/>
@@ -10214,7 +10214,7 @@
               <a:spcAft>
                 <a:spcPts val="500"/>
               </a:spcAft>
-              <a:defRPr sz="1500" b="0">
+              <a:defRPr sz="1300" b="0">
                 <a:solidFill>
                   <a:srgbClr val="26313B"/>
                 </a:solidFill>
@@ -10229,7 +10229,169 @@
       </p:sp>
       <p:sp>
         <p:nvSpPr>
-          <p:cNvPr id="30" name="TextBox 29"/>
+          <p:cNvPr id="30" name="Rounded Rectangle 29"/>
+          <p:cNvSpPr/>
+          <p:nvPr/>
+        </p:nvSpPr>
+        <p:spPr>
+          <a:xfrm>
+            <a:off x="7132320" y="3877056"/>
+            <a:ext cx="4069080" cy="1207008"/>
+          </a:xfrm>
+          <a:prstGeom prst="roundRect">
+            <a:avLst/>
+          </a:prstGeom>
+          <a:solidFill>
+            <a:srgbClr val="E7F5F3"/>
+          </a:solidFill>
+          <a:ln w="13970">
+            <a:solidFill>
+              <a:srgbClr val="E7F5F3"/>
+            </a:solidFill>
+          </a:ln>
+        </p:spPr>
+        <p:style>
+          <a:lnRef idx="1">
+            <a:schemeClr val="accent1"/>
+          </a:lnRef>
+          <a:fillRef idx="3">
+            <a:schemeClr val="accent1"/>
+          </a:fillRef>
+          <a:effectRef idx="2">
+            <a:schemeClr val="accent1"/>
+          </a:effectRef>
+          <a:fontRef idx="minor">
+            <a:schemeClr val="lt1"/>
+          </a:fontRef>
+        </p:style>
+        <p:txBody>
+          <a:bodyPr rtlCol="0" anchor="ctr"/>
+          <a:lstStyle/>
+          <a:p>
+            <a:pPr algn="ctr"/>
+          </a:p>
+        </p:txBody>
+      </p:sp>
+      <p:sp>
+        <p:nvSpPr>
+          <p:cNvPr id="31" name="TextBox 30"/>
+          <p:cNvSpPr txBox="1"/>
+          <p:nvPr/>
+        </p:nvSpPr>
+        <p:spPr>
+          <a:xfrm>
+            <a:off x="7388352" y="4023360"/>
+            <a:ext cx="3566160" cy="237744"/>
+          </a:xfrm>
+          <a:prstGeom prst="rect">
+            <a:avLst/>
+          </a:prstGeom>
+          <a:noFill/>
+        </p:spPr>
+        <p:txBody>
+          <a:bodyPr wrap="square" lIns="36576" rIns="36576" tIns="36576" bIns="36576" anchor="t">
+            <a:spAutoFit/>
+          </a:bodyPr>
+          <a:lstStyle/>
+          <a:p>
+            <a:pPr algn="l">
+              <a:spcAft>
+                <a:spcPts val="500"/>
+              </a:spcAft>
+              <a:defRPr sz="1000" b="1">
+                <a:solidFill>
+                  <a:srgbClr val="1C8585"/>
+                </a:solidFill>
+                <a:latin typeface="Aptos"/>
+              </a:defRPr>
+            </a:pPr>
+            <a:r>
+              <a:t>ILLUSTRATIVE MODEL OUTPUT</a:t>
+            </a:r>
+          </a:p>
+        </p:txBody>
+      </p:sp>
+      <p:sp>
+        <p:nvSpPr>
+          <p:cNvPr id="32" name="TextBox 31"/>
+          <p:cNvSpPr txBox="1"/>
+          <p:nvPr/>
+        </p:nvSpPr>
+        <p:spPr>
+          <a:xfrm>
+            <a:off x="7388352" y="4343400"/>
+            <a:ext cx="566928" cy="310896"/>
+          </a:xfrm>
+          <a:prstGeom prst="rect">
+            <a:avLst/>
+          </a:prstGeom>
+          <a:noFill/>
+        </p:spPr>
+        <p:txBody>
+          <a:bodyPr wrap="square" lIns="36576" rIns="36576" tIns="36576" bIns="36576" anchor="t">
+            <a:spAutoFit/>
+          </a:bodyPr>
+          <a:lstStyle/>
+          <a:p>
+            <a:pPr algn="l">
+              <a:spcAft>
+                <a:spcPts val="500"/>
+              </a:spcAft>
+              <a:defRPr sz="1700" b="1">
+                <a:solidFill>
+                  <a:srgbClr val="1C8585"/>
+                </a:solidFill>
+                <a:latin typeface="Aptos"/>
+              </a:defRPr>
+            </a:pPr>
+            <a:r>
+              <a:t>YES</a:t>
+            </a:r>
+          </a:p>
+        </p:txBody>
+      </p:sp>
+      <p:sp>
+        <p:nvSpPr>
+          <p:cNvPr id="33" name="TextBox 32"/>
+          <p:cNvSpPr txBox="1"/>
+          <p:nvPr/>
+        </p:nvSpPr>
+        <p:spPr>
+          <a:xfrm>
+            <a:off x="8028431" y="4288536"/>
+            <a:ext cx="2907792" cy="603504"/>
+          </a:xfrm>
+          <a:prstGeom prst="rect">
+            <a:avLst/>
+          </a:prstGeom>
+          <a:noFill/>
+        </p:spPr>
+        <p:txBody>
+          <a:bodyPr wrap="square" lIns="36576" rIns="36576" tIns="36576" bIns="36576" anchor="t">
+            <a:spAutoFit/>
+          </a:bodyPr>
+          <a:lstStyle/>
+          <a:p>
+            <a:pPr algn="l">
+              <a:spcAft>
+                <a:spcPts val="500"/>
+              </a:spcAft>
+              <a:defRPr sz="1300" b="0">
+                <a:solidFill>
+                  <a:srgbClr val="26313B"/>
+                </a:solidFill>
+                <a:latin typeface="Aptos"/>
+              </a:defRPr>
+            </a:pPr>
+            <a:r>
+              <a:t>“When appropriate” leaves the retry condition open.</a:t>
+            </a:r>
+          </a:p>
+        </p:txBody>
+      </p:sp>
+      <p:sp>
+        <p:nvSpPr>
+          <p:cNvPr id="34" name="TextBox 33"/>
           <p:cNvSpPr txBox="1"/>
           <p:nvPr/>
         </p:nvSpPr>
@@ -10268,7 +10430,7 @@
       </p:sp>
       <p:sp>
         <p:nvSpPr>
-          <p:cNvPr id="31" name="TextBox 30"/>
+          <p:cNvPr id="35" name="TextBox 34"/>
           <p:cNvSpPr txBox="1"/>
           <p:nvPr/>
         </p:nvSpPr>
@@ -10307,7 +10469,7 @@
       </p:sp>
       <p:sp>
         <p:nvSpPr>
-          <p:cNvPr id="32" name="TextBox 31"/>
+          <p:cNvPr id="36" name="TextBox 35"/>
           <p:cNvSpPr txBox="1"/>
           <p:nvPr/>
         </p:nvSpPr>

</xml_diff>

<commit_message>
presentation: add GUI screenshots and update figures
</commit_message>
<xml_diff>
--- a/paper/presentation/ietf_ambiguity_detection_presentation.pptx
+++ b/paper/presentation/ietf_ambiguity_detection_presentation.pptx
@@ -5309,7 +5309,7 @@
               </a:defRPr>
             </a:pPr>
             <a:r>
-              <a:t>Latest DeBERTa study: encouraging ranking, wide uncertainty</a:t>
+              <a:t>Latest DeBERTa comparison: promising ranking, wide uncertainty</a:t>
             </a:r>
           </a:p>
         </p:txBody>
@@ -5461,7 +5461,7 @@
               </a:defRPr>
             </a:pPr>
             <a:r>
-              <a:t>2,125 clauses  ·  136 positives  ·  9 families  ·  5-fold family-isolated OOF</a:t>
+              <a:t>2,143 clauses  ·  138 positives  ·  9 families  ·  5-fold family-isolated OOF</a:t>
             </a:r>
           </a:p>
         </p:txBody>
@@ -5474,7 +5474,7 @@
         </p:nvCxnSpPr>
         <p:spPr>
           <a:xfrm>
-            <a:off x="4497850" y="1975104"/>
+            <a:off x="4397459" y="1975104"/>
             <a:ext cx="0" cy="2523744"/>
           </a:xfrm>
           <a:prstGeom prst="line">
@@ -5509,7 +5509,7 @@
         </p:nvSpPr>
         <p:spPr>
           <a:xfrm>
-            <a:off x="4534426" y="1764792"/>
+            <a:off x="4434035" y="1764792"/>
             <a:ext cx="1005840" cy="201168"/>
           </a:xfrm>
           <a:prstGeom prst="rect">
@@ -5588,7 +5588,7 @@
         <p:spPr>
           <a:xfrm>
             <a:off x="4114800" y="2084832"/>
-            <a:ext cx="2221094" cy="310896"/>
+            <a:ext cx="2956511" cy="310896"/>
           </a:xfrm>
           <a:prstGeom prst="rect">
             <a:avLst/>
@@ -5632,7 +5632,7 @@
         </p:nvSpPr>
         <p:spPr>
           <a:xfrm>
-            <a:off x="6418190" y="2057400"/>
+            <a:off x="7153607" y="2057400"/>
             <a:ext cx="566928" cy="320040"/>
           </a:xfrm>
           <a:prstGeom prst="rect">
@@ -5658,7 +5658,7 @@
               </a:defRPr>
             </a:pPr>
             <a:r>
-              <a:t>0.3711</a:t>
+              <a:t>0.6736</a:t>
             </a:r>
           </a:p>
         </p:txBody>
@@ -5697,7 +5697,7 @@
               </a:defRPr>
             </a:pPr>
             <a:r>
-              <a:t>Partial fine-tuning</a:t>
+              <a:t>Focal loss</a:t>
             </a:r>
           </a:p>
         </p:txBody>
@@ -5711,7 +5711,130 @@
         <p:spPr>
           <a:xfrm>
             <a:off x="4114800" y="2724912"/>
-            <a:ext cx="1952360" cy="310896"/>
+            <a:ext cx="2555784" cy="310896"/>
+          </a:xfrm>
+          <a:prstGeom prst="rect">
+            <a:avLst/>
+          </a:prstGeom>
+          <a:solidFill>
+            <a:srgbClr val="DA8B35"/>
+          </a:solidFill>
+          <a:ln>
+            <a:solidFill>
+              <a:srgbClr val="DA8B35"/>
+            </a:solidFill>
+          </a:ln>
+        </p:spPr>
+        <p:style>
+          <a:lnRef idx="1">
+            <a:schemeClr val="accent1"/>
+          </a:lnRef>
+          <a:fillRef idx="3">
+            <a:schemeClr val="accent1"/>
+          </a:fillRef>
+          <a:effectRef idx="2">
+            <a:schemeClr val="accent1"/>
+          </a:effectRef>
+          <a:fontRef idx="minor">
+            <a:schemeClr val="lt1"/>
+          </a:fontRef>
+        </p:style>
+        <p:txBody>
+          <a:bodyPr rtlCol="0" anchor="ctr"/>
+          <a:lstStyle/>
+          <a:p>
+            <a:pPr algn="ctr"/>
+          </a:p>
+        </p:txBody>
+      </p:sp>
+      <p:sp>
+        <p:nvSpPr>
+          <p:cNvPr id="14" name="TextBox 13"/>
+          <p:cNvSpPr txBox="1"/>
+          <p:nvPr/>
+        </p:nvSpPr>
+        <p:spPr>
+          <a:xfrm>
+            <a:off x="6752880" y="2697480"/>
+            <a:ext cx="566928" cy="320040"/>
+          </a:xfrm>
+          <a:prstGeom prst="rect">
+            <a:avLst/>
+          </a:prstGeom>
+          <a:noFill/>
+        </p:spPr>
+        <p:txBody>
+          <a:bodyPr wrap="square" lIns="36576" rIns="36576" tIns="36576" bIns="36576" anchor="t">
+            <a:spAutoFit/>
+          </a:bodyPr>
+          <a:lstStyle/>
+          <a:p>
+            <a:pPr algn="l">
+              <a:spcAft>
+                <a:spcPts val="500"/>
+              </a:spcAft>
+              <a:defRPr sz="1200" b="1">
+                <a:solidFill>
+                  <a:srgbClr val="26313B"/>
+                </a:solidFill>
+                <a:latin typeface="Aptos"/>
+              </a:defRPr>
+            </a:pPr>
+            <a:r>
+              <a:t>0.5823</a:t>
+            </a:r>
+          </a:p>
+        </p:txBody>
+      </p:sp>
+      <p:sp>
+        <p:nvSpPr>
+          <p:cNvPr id="15" name="TextBox 14"/>
+          <p:cNvSpPr txBox="1"/>
+          <p:nvPr/>
+        </p:nvSpPr>
+        <p:spPr>
+          <a:xfrm>
+            <a:off x="1051560" y="3328416"/>
+            <a:ext cx="2953512" cy="347472"/>
+          </a:xfrm>
+          <a:prstGeom prst="rect">
+            <a:avLst/>
+          </a:prstGeom>
+          <a:noFill/>
+        </p:spPr>
+        <p:txBody>
+          <a:bodyPr wrap="square" lIns="36576" rIns="36576" tIns="36576" bIns="36576" anchor="t">
+            <a:spAutoFit/>
+          </a:bodyPr>
+          <a:lstStyle/>
+          <a:p>
+            <a:pPr algn="l">
+              <a:spcAft>
+                <a:spcPts val="500"/>
+              </a:spcAft>
+              <a:defRPr sz="1400" b="0">
+                <a:solidFill>
+                  <a:srgbClr val="26313B"/>
+                </a:solidFill>
+                <a:latin typeface="Aptos"/>
+              </a:defRPr>
+            </a:pPr>
+            <a:r>
+              <a:t>Partial fine-tuning</a:t>
+            </a:r>
+          </a:p>
+        </p:txBody>
+      </p:sp>
+      <p:sp>
+        <p:nvSpPr>
+          <p:cNvPr id="16" name="Rectangle 15"/>
+          <p:cNvSpPr/>
+          <p:nvPr/>
+        </p:nvSpPr>
+        <p:spPr>
+          <a:xfrm>
+            <a:off x="4114800" y="3364992"/>
+            <a:ext cx="2528572" cy="310896"/>
           </a:xfrm>
           <a:prstGeom prst="rect">
             <a:avLst/>
@@ -5749,13 +5872,13 @@
       </p:sp>
       <p:sp>
         <p:nvSpPr>
-          <p:cNvPr id="14" name="TextBox 13"/>
-          <p:cNvSpPr txBox="1"/>
-          <p:nvPr/>
-        </p:nvSpPr>
-        <p:spPr>
-          <a:xfrm>
-            <a:off x="6149456" y="2697480"/>
+          <p:cNvPr id="17" name="TextBox 16"/>
+          <p:cNvSpPr txBox="1"/>
+          <p:nvPr/>
+        </p:nvSpPr>
+        <p:spPr>
+          <a:xfrm>
+            <a:off x="6725668" y="3337560"/>
             <a:ext cx="566928" cy="320040"/>
           </a:xfrm>
           <a:prstGeom prst="rect">
@@ -5781,130 +5904,7 @@
               </a:defRPr>
             </a:pPr>
             <a:r>
-              <a:t>0.3262</a:t>
-            </a:r>
-          </a:p>
-        </p:txBody>
-      </p:sp>
-      <p:sp>
-        <p:nvSpPr>
-          <p:cNvPr id="15" name="TextBox 14"/>
-          <p:cNvSpPr txBox="1"/>
-          <p:nvPr/>
-        </p:nvSpPr>
-        <p:spPr>
-          <a:xfrm>
-            <a:off x="1051560" y="3328416"/>
-            <a:ext cx="2953512" cy="347472"/>
-          </a:xfrm>
-          <a:prstGeom prst="rect">
-            <a:avLst/>
-          </a:prstGeom>
-          <a:noFill/>
-        </p:spPr>
-        <p:txBody>
-          <a:bodyPr wrap="square" lIns="36576" rIns="36576" tIns="36576" bIns="36576" anchor="t">
-            <a:spAutoFit/>
-          </a:bodyPr>
-          <a:lstStyle/>
-          <a:p>
-            <a:pPr algn="l">
-              <a:spcAft>
-                <a:spcPts val="500"/>
-              </a:spcAft>
-              <a:defRPr sz="1400" b="0">
-                <a:solidFill>
-                  <a:srgbClr val="26313B"/>
-                </a:solidFill>
-                <a:latin typeface="Aptos"/>
-              </a:defRPr>
-            </a:pPr>
-            <a:r>
-              <a:t>Focal loss</a:t>
-            </a:r>
-          </a:p>
-        </p:txBody>
-      </p:sp>
-      <p:sp>
-        <p:nvSpPr>
-          <p:cNvPr id="16" name="Rectangle 15"/>
-          <p:cNvSpPr/>
-          <p:nvPr/>
-        </p:nvSpPr>
-        <p:spPr>
-          <a:xfrm>
-            <a:off x="4114800" y="3364992"/>
-            <a:ext cx="1827868" cy="310896"/>
-          </a:xfrm>
-          <a:prstGeom prst="rect">
-            <a:avLst/>
-          </a:prstGeom>
-          <a:solidFill>
-            <a:srgbClr val="DA8B35"/>
-          </a:solidFill>
-          <a:ln>
-            <a:solidFill>
-              <a:srgbClr val="DA8B35"/>
-            </a:solidFill>
-          </a:ln>
-        </p:spPr>
-        <p:style>
-          <a:lnRef idx="1">
-            <a:schemeClr val="accent1"/>
-          </a:lnRef>
-          <a:fillRef idx="3">
-            <a:schemeClr val="accent1"/>
-          </a:fillRef>
-          <a:effectRef idx="2">
-            <a:schemeClr val="accent1"/>
-          </a:effectRef>
-          <a:fontRef idx="minor">
-            <a:schemeClr val="lt1"/>
-          </a:fontRef>
-        </p:style>
-        <p:txBody>
-          <a:bodyPr rtlCol="0" anchor="ctr"/>
-          <a:lstStyle/>
-          <a:p>
-            <a:pPr algn="ctr"/>
-          </a:p>
-        </p:txBody>
-      </p:sp>
-      <p:sp>
-        <p:nvSpPr>
-          <p:cNvPr id="17" name="TextBox 16"/>
-          <p:cNvSpPr txBox="1"/>
-          <p:nvPr/>
-        </p:nvSpPr>
-        <p:spPr>
-          <a:xfrm>
-            <a:off x="6024964" y="3337560"/>
-            <a:ext cx="566928" cy="320040"/>
-          </a:xfrm>
-          <a:prstGeom prst="rect">
-            <a:avLst/>
-          </a:prstGeom>
-          <a:noFill/>
-        </p:spPr>
-        <p:txBody>
-          <a:bodyPr wrap="square" lIns="36576" rIns="36576" tIns="36576" bIns="36576" anchor="t">
-            <a:spAutoFit/>
-          </a:bodyPr>
-          <a:lstStyle/>
-          <a:p>
-            <a:pPr algn="l">
-              <a:spcAft>
-                <a:spcPts val="500"/>
-              </a:spcAft>
-              <a:defRPr sz="1200" b="1">
-                <a:solidFill>
-                  <a:srgbClr val="26313B"/>
-                </a:solidFill>
-                <a:latin typeface="Aptos"/>
-              </a:defRPr>
-            </a:pPr>
-            <a:r>
-              <a:t>0.3054</a:t>
+              <a:t>0.5761</a:t>
             </a:r>
           </a:p>
         </p:txBody>
@@ -5957,7 +5957,7 @@
         <p:spPr>
           <a:xfrm>
             <a:off x="4114800" y="4005072"/>
-            <a:ext cx="383050" cy="310896"/>
+            <a:ext cx="282659" cy="310896"/>
           </a:xfrm>
           <a:prstGeom prst="rect">
             <a:avLst/>
@@ -6001,7 +6001,7 @@
         </p:nvSpPr>
         <p:spPr>
           <a:xfrm>
-            <a:off x="4580146" y="3977639"/>
+            <a:off x="4479755" y="3977639"/>
             <a:ext cx="566928" cy="320040"/>
           </a:xfrm>
           <a:prstGeom prst="rect">
@@ -6027,7 +6027,7 @@
               </a:defRPr>
             </a:pPr>
             <a:r>
-              <a:t>0.0640</a:t>
+              <a:t>0.0644</a:t>
             </a:r>
           </a:p>
         </p:txBody>
@@ -6111,7 +6111,7 @@
               </a:defRPr>
             </a:pPr>
             <a:r>
-              <a:t>26 / 50</a:t>
+              <a:t>46 / 50</a:t>
             </a:r>
           </a:p>
         </p:txBody>
@@ -6189,7 +6189,7 @@
               </a:defRPr>
             </a:pPr>
             <a:r>
-              <a:t>AP family-cluster interval: 0.315–0.508</a:t>
+              <a:t>Ensemble AP family interval: 0.592–0.764</a:t>
             </a:r>
           </a:p>
         </p:txBody>
@@ -6202,8 +6202,8 @@
         </p:nvSpPr>
         <p:spPr>
           <a:xfrm>
-            <a:off x="1005840" y="5166360"/>
-            <a:ext cx="10149840" cy="566928"/>
+            <a:off x="1005840" y="4892040"/>
+            <a:ext cx="10149840" cy="868680"/>
           </a:xfrm>
           <a:prstGeom prst="rect">
             <a:avLst/>
@@ -6220,7 +6220,7 @@
               <a:spcAft>
                 <a:spcPts val="500"/>
               </a:spcAft>
-              <a:defRPr sz="1600" b="1">
+              <a:defRPr sz="1400" b="1">
                 <a:solidFill>
                   <a:srgbClr val="A6413E"/>
                 </a:solidFill>
@@ -6228,7 +6228,7 @@
               </a:defRPr>
             </a:pPr>
             <a:r>
-              <a:t>The interval resamples only nine families; it does not capture training-seed variation or test-set uncertainty.</a:t>
+              <a:t>The ECDF ensemble is a ranking score, not a calibrated probability. Intervals overlap across nine families; the 100 labels were error-selected, and this repair reuses parent predictions—not an independent test.</a:t>
             </a:r>
           </a:p>
         </p:txBody>
@@ -6267,7 +6267,7 @@
               </a:defRPr>
             </a:pPr>
             <a:r>
-              <a:t>Source: paper/main.tex, Table ranking and fixed-review-budget results.</a:t>
+              <a:t>Source: updated reviewed-label DeBERTa outputs; paper/main.tex. OOF development results.</a:t>
             </a:r>
           </a:p>
         </p:txBody>
@@ -9152,7 +9152,7 @@
               </a:defRPr>
             </a:pPr>
             <a:r>
-              <a:t>The right role is an explainable reviewer aid</a:t>
+              <a:t>GUI example: RFC 9000 review results</a:t>
             </a:r>
           </a:p>
         </p:txBody>
@@ -9226,7 +9226,7 @@
               </a:defRPr>
             </a:pPr>
             <a:r>
-              <a:t>RESPONSIBLE USE</a:t>
+              <a:t>INTERFACE</a:t>
             </a:r>
           </a:p>
         </p:txBody>
@@ -9278,8 +9278,8 @@
         </p:nvSpPr>
         <p:spPr>
           <a:xfrm>
-            <a:off x="914400" y="1280160"/>
-            <a:ext cx="4572000" cy="438912"/>
+            <a:off x="822960" y="1234440"/>
+            <a:ext cx="5303520" cy="347472"/>
           </a:xfrm>
           <a:prstGeom prst="rect">
             <a:avLst/>
@@ -9296,7 +9296,7 @@
               <a:spcAft>
                 <a:spcPts val="500"/>
               </a:spcAft>
-              <a:defRPr sz="2100" b="1">
+              <a:defRPr sz="2000" b="1">
                 <a:solidFill>
                   <a:srgbClr val="183452"/>
                 </a:solidFill>
@@ -9304,30 +9304,32 @@
               </a:defRPr>
             </a:pPr>
             <a:r>
-              <a:t>A human-in-the-loop workflow</a:t>
-            </a:r>
-          </a:p>
-        </p:txBody>
-      </p:sp>
-      <p:sp>
-        <p:nvSpPr>
-          <p:cNvPr id="7" name="Oval 6"/>
+              <a:t>Local scan summary</a:t>
+            </a:r>
+          </a:p>
+        </p:txBody>
+      </p:sp>
+      <p:sp>
+        <p:nvSpPr>
+          <p:cNvPr id="7" name="Rounded Rectangle 6"/>
           <p:cNvSpPr/>
           <p:nvPr/>
         </p:nvSpPr>
         <p:spPr>
           <a:xfrm>
-            <a:off x="1005840" y="1965960"/>
-            <a:ext cx="411480" cy="411480"/>
-          </a:xfrm>
-          <a:prstGeom prst="ellipse">
+            <a:off x="822960" y="1719072"/>
+            <a:ext cx="1572768" cy="1069848"/>
+          </a:xfrm>
+          <a:prstGeom prst="roundRect">
             <a:avLst/>
           </a:prstGeom>
           <a:solidFill>
-            <a:srgbClr val="2D6596"/>
+            <a:srgbClr val="E7F0F7"/>
           </a:solidFill>
-          <a:ln>
-            <a:noFill/>
+          <a:ln w="13970">
+            <a:solidFill>
+              <a:srgbClr val="E7F0F7"/>
+            </a:solidFill>
           </a:ln>
         </p:spPr>
         <p:style>
@@ -9360,16 +9362,16 @@
         </p:nvSpPr>
         <p:spPr>
           <a:xfrm>
-            <a:off x="1005840" y="1970531"/>
-            <a:ext cx="411480" cy="402336"/>
-          </a:xfrm>
-          <a:prstGeom prst="rect">
-            <a:avLst/>
-          </a:prstGeom>
-          <a:noFill/>
-        </p:spPr>
-        <p:txBody>
-          <a:bodyPr wrap="square" lIns="0" rIns="0" tIns="0" bIns="0" anchor="ctr">
+            <a:off x="896112" y="1828800"/>
+            <a:ext cx="1426464" cy="393192"/>
+          </a:xfrm>
+          <a:prstGeom prst="rect">
+            <a:avLst/>
+          </a:prstGeom>
+          <a:noFill/>
+        </p:spPr>
+        <p:txBody>
+          <a:bodyPr wrap="square" lIns="36576" rIns="36576" tIns="36576" bIns="36576" anchor="t">
             <a:spAutoFit/>
           </a:bodyPr>
           <a:lstStyle/>
@@ -9378,15 +9380,15 @@
               <a:spcAft>
                 <a:spcPts val="500"/>
               </a:spcAft>
-              <a:defRPr sz="1600" b="1">
-                <a:solidFill>
-                  <a:srgbClr val="FFFFFF"/>
-                </a:solidFill>
-                <a:latin typeface="Aptos"/>
-              </a:defRPr>
-            </a:pPr>
-            <a:r>
-              <a:t>1</a:t>
+              <a:defRPr sz="2700" b="1">
+                <a:solidFill>
+                  <a:srgbClr val="1C8585"/>
+                </a:solidFill>
+                <a:latin typeface="Aptos"/>
+              </a:defRPr>
+            </a:pPr>
+            <a:r>
+              <a:t>112</a:t>
             </a:r>
           </a:p>
         </p:txBody>
@@ -9399,64 +9401,25 @@
         </p:nvSpPr>
         <p:spPr>
           <a:xfrm>
-            <a:off x="1600200" y="1956816"/>
-            <a:ext cx="1325880" cy="320040"/>
-          </a:xfrm>
-          <a:prstGeom prst="rect">
-            <a:avLst/>
-          </a:prstGeom>
-          <a:noFill/>
-        </p:spPr>
-        <p:txBody>
-          <a:bodyPr wrap="square" lIns="36576" rIns="36576" tIns="36576" bIns="36576" anchor="t">
-            <a:spAutoFit/>
-          </a:bodyPr>
-          <a:lstStyle/>
-          <a:p>
-            <a:pPr algn="l">
-              <a:spcAft>
-                <a:spcPts val="500"/>
-              </a:spcAft>
-              <a:defRPr sz="1800" b="1">
-                <a:solidFill>
-                  <a:srgbClr val="183452"/>
-                </a:solidFill>
-                <a:latin typeface="Aptos"/>
-              </a:defRPr>
-            </a:pPr>
-            <a:r>
-              <a:t>Rank</a:t>
-            </a:r>
-          </a:p>
-        </p:txBody>
-      </p:sp>
-      <p:sp>
-        <p:nvSpPr>
-          <p:cNvPr id="10" name="TextBox 9"/>
-          <p:cNvSpPr txBox="1"/>
-          <p:nvPr/>
-        </p:nvSpPr>
-        <p:spPr>
-          <a:xfrm>
-            <a:off x="2880360" y="1956816"/>
-            <a:ext cx="3657600" cy="512064"/>
-          </a:xfrm>
-          <a:prstGeom prst="rect">
-            <a:avLst/>
-          </a:prstGeom>
-          <a:noFill/>
-        </p:spPr>
-        <p:txBody>
-          <a:bodyPr wrap="square" lIns="36576" rIns="36576" tIns="36576" bIns="36576" anchor="t">
-            <a:spAutoFit/>
-          </a:bodyPr>
-          <a:lstStyle/>
-          <a:p>
-            <a:pPr algn="l">
-              <a:spcAft>
-                <a:spcPts val="500"/>
-              </a:spcAft>
-              <a:defRPr sz="1600" b="0">
+            <a:off x="896112" y="2286000"/>
+            <a:ext cx="1426464" cy="384048"/>
+          </a:xfrm>
+          <a:prstGeom prst="rect">
+            <a:avLst/>
+          </a:prstGeom>
+          <a:noFill/>
+        </p:spPr>
+        <p:txBody>
+          <a:bodyPr wrap="square" lIns="36576" rIns="36576" tIns="36576" bIns="36576" anchor="t">
+            <a:spAutoFit/>
+          </a:bodyPr>
+          <a:lstStyle/>
+          <a:p>
+            <a:pPr algn="ctr">
+              <a:spcAft>
+                <a:spcPts val="500"/>
+              </a:spcAft>
+              <a:defRPr sz="1100" b="0">
                 <a:solidFill>
                   <a:srgbClr val="26313B"/>
                 </a:solidFill>
@@ -9464,30 +9427,48 @@
               </a:defRPr>
             </a:pPr>
             <a:r>
-              <a:t>Surface clauses worth a closer read</a:t>
-            </a:r>
-          </a:p>
-        </p:txBody>
-      </p:sp>
-      <p:sp>
-        <p:nvSpPr>
-          <p:cNvPr id="11" name="Oval 10"/>
+              <a:t>potentially</a:t>
+            </a:r>
+          </a:p>
+          <a:p>
+            <a:pPr algn="ctr">
+              <a:spcAft>
+                <a:spcPts val="500"/>
+              </a:spcAft>
+              <a:defRPr sz="1100" b="0">
+                <a:solidFill>
+                  <a:srgbClr val="26313B"/>
+                </a:solidFill>
+                <a:latin typeface="Aptos"/>
+              </a:defRPr>
+            </a:pPr>
+            <a:r>
+              <a:t>ambiguous</a:t>
+            </a:r>
+          </a:p>
+        </p:txBody>
+      </p:sp>
+      <p:sp>
+        <p:nvSpPr>
+          <p:cNvPr id="10" name="Rounded Rectangle 9"/>
           <p:cNvSpPr/>
           <p:nvPr/>
         </p:nvSpPr>
         <p:spPr>
           <a:xfrm>
-            <a:off x="1005840" y="3008376"/>
-            <a:ext cx="411480" cy="411480"/>
-          </a:xfrm>
-          <a:prstGeom prst="ellipse">
+            <a:off x="2578608" y="1719072"/>
+            <a:ext cx="1572768" cy="1069848"/>
+          </a:xfrm>
+          <a:prstGeom prst="roundRect">
             <a:avLst/>
           </a:prstGeom>
           <a:solidFill>
-            <a:srgbClr val="1C8585"/>
+            <a:srgbClr val="E7F0F7"/>
           </a:solidFill>
-          <a:ln>
-            <a:noFill/>
+          <a:ln w="13970">
+            <a:solidFill>
+              <a:srgbClr val="E7F0F7"/>
+            </a:solidFill>
           </a:ln>
         </p:spPr>
         <p:style>
@@ -9514,22 +9495,61 @@
       </p:sp>
       <p:sp>
         <p:nvSpPr>
+          <p:cNvPr id="11" name="TextBox 10"/>
+          <p:cNvSpPr txBox="1"/>
+          <p:nvPr/>
+        </p:nvSpPr>
+        <p:spPr>
+          <a:xfrm>
+            <a:off x="2651760" y="1828800"/>
+            <a:ext cx="1426464" cy="393192"/>
+          </a:xfrm>
+          <a:prstGeom prst="rect">
+            <a:avLst/>
+          </a:prstGeom>
+          <a:noFill/>
+        </p:spPr>
+        <p:txBody>
+          <a:bodyPr wrap="square" lIns="36576" rIns="36576" tIns="36576" bIns="36576" anchor="t">
+            <a:spAutoFit/>
+          </a:bodyPr>
+          <a:lstStyle/>
+          <a:p>
+            <a:pPr algn="ctr">
+              <a:spcAft>
+                <a:spcPts val="500"/>
+              </a:spcAft>
+              <a:defRPr sz="2700" b="1">
+                <a:solidFill>
+                  <a:srgbClr val="2D6596"/>
+                </a:solidFill>
+                <a:latin typeface="Aptos"/>
+              </a:defRPr>
+            </a:pPr>
+            <a:r>
+              <a:t>516</a:t>
+            </a:r>
+          </a:p>
+        </p:txBody>
+      </p:sp>
+      <p:sp>
+        <p:nvSpPr>
           <p:cNvPr id="12" name="TextBox 11"/>
           <p:cNvSpPr txBox="1"/>
           <p:nvPr/>
         </p:nvSpPr>
         <p:spPr>
           <a:xfrm>
-            <a:off x="1005840" y="3012948"/>
-            <a:ext cx="411480" cy="402336"/>
-          </a:xfrm>
-          <a:prstGeom prst="rect">
-            <a:avLst/>
-          </a:prstGeom>
-          <a:noFill/>
-        </p:spPr>
-        <p:txBody>
-          <a:bodyPr wrap="square" lIns="0" rIns="0" tIns="0" bIns="0" anchor="ctr">
+            <a:off x="2651760" y="2286000"/>
+            <a:ext cx="1426464" cy="384048"/>
+          </a:xfrm>
+          <a:prstGeom prst="rect">
+            <a:avLst/>
+          </a:prstGeom>
+          <a:noFill/>
+        </p:spPr>
+        <p:txBody>
+          <a:bodyPr wrap="square" lIns="36576" rIns="36576" tIns="36576" bIns="36576" anchor="t">
             <a:spAutoFit/>
           </a:bodyPr>
           <a:lstStyle/>
@@ -9538,85 +9558,7 @@
               <a:spcAft>
                 <a:spcPts val="500"/>
               </a:spcAft>
-              <a:defRPr sz="1600" b="1">
-                <a:solidFill>
-                  <a:srgbClr val="FFFFFF"/>
-                </a:solidFill>
-                <a:latin typeface="Aptos"/>
-              </a:defRPr>
-            </a:pPr>
-            <a:r>
-              <a:t>2</a:t>
-            </a:r>
-          </a:p>
-        </p:txBody>
-      </p:sp>
-      <p:sp>
-        <p:nvSpPr>
-          <p:cNvPr id="13" name="TextBox 12"/>
-          <p:cNvSpPr txBox="1"/>
-          <p:nvPr/>
-        </p:nvSpPr>
-        <p:spPr>
-          <a:xfrm>
-            <a:off x="1600200" y="2999232"/>
-            <a:ext cx="1325880" cy="320040"/>
-          </a:xfrm>
-          <a:prstGeom prst="rect">
-            <a:avLst/>
-          </a:prstGeom>
-          <a:noFill/>
-        </p:spPr>
-        <p:txBody>
-          <a:bodyPr wrap="square" lIns="36576" rIns="36576" tIns="36576" bIns="36576" anchor="t">
-            <a:spAutoFit/>
-          </a:bodyPr>
-          <a:lstStyle/>
-          <a:p>
-            <a:pPr algn="l">
-              <a:spcAft>
-                <a:spcPts val="500"/>
-              </a:spcAft>
-              <a:defRPr sz="1800" b="1">
-                <a:solidFill>
-                  <a:srgbClr val="183452"/>
-                </a:solidFill>
-                <a:latin typeface="Aptos"/>
-              </a:defRPr>
-            </a:pPr>
-            <a:r>
-              <a:t>Inspect</a:t>
-            </a:r>
-          </a:p>
-        </p:txBody>
-      </p:sp>
-      <p:sp>
-        <p:nvSpPr>
-          <p:cNvPr id="14" name="TextBox 13"/>
-          <p:cNvSpPr txBox="1"/>
-          <p:nvPr/>
-        </p:nvSpPr>
-        <p:spPr>
-          <a:xfrm>
-            <a:off x="2880360" y="2999232"/>
-            <a:ext cx="3657600" cy="512064"/>
-          </a:xfrm>
-          <a:prstGeom prst="rect">
-            <a:avLst/>
-          </a:prstGeom>
-          <a:noFill/>
-        </p:spPr>
-        <p:txBody>
-          <a:bodyPr wrap="square" lIns="36576" rIns="36576" tIns="36576" bIns="36576" anchor="t">
-            <a:spAutoFit/>
-          </a:bodyPr>
-          <a:lstStyle/>
-          <a:p>
-            <a:pPr algn="l">
-              <a:spcAft>
-                <a:spcPts val="500"/>
-              </a:spcAft>
-              <a:defRPr sz="1600" b="0">
+              <a:defRPr sz="1100" b="0">
                 <a:solidFill>
                   <a:srgbClr val="26313B"/>
                 </a:solidFill>
@@ -9624,30 +9566,48 @@
               </a:defRPr>
             </a:pPr>
             <a:r>
-              <a:t>Return to the exact draft text and context</a:t>
-            </a:r>
-          </a:p>
-        </p:txBody>
-      </p:sp>
-      <p:sp>
-        <p:nvSpPr>
-          <p:cNvPr id="15" name="Oval 14"/>
+              <a:t>normative clauses</a:t>
+            </a:r>
+          </a:p>
+          <a:p>
+            <a:pPr algn="ctr">
+              <a:spcAft>
+                <a:spcPts val="500"/>
+              </a:spcAft>
+              <a:defRPr sz="1100" b="0">
+                <a:solidFill>
+                  <a:srgbClr val="26313B"/>
+                </a:solidFill>
+                <a:latin typeface="Aptos"/>
+              </a:defRPr>
+            </a:pPr>
+            <a:r>
+              <a:t>scored</a:t>
+            </a:r>
+          </a:p>
+        </p:txBody>
+      </p:sp>
+      <p:sp>
+        <p:nvSpPr>
+          <p:cNvPr id="13" name="Rounded Rectangle 12"/>
           <p:cNvSpPr/>
           <p:nvPr/>
         </p:nvSpPr>
         <p:spPr>
           <a:xfrm>
-            <a:off x="1005840" y="4050791"/>
-            <a:ext cx="411480" cy="411480"/>
-          </a:xfrm>
-          <a:prstGeom prst="ellipse">
+            <a:off x="4334256" y="1719072"/>
+            <a:ext cx="1572768" cy="1069848"/>
+          </a:xfrm>
+          <a:prstGeom prst="roundRect">
             <a:avLst/>
           </a:prstGeom>
           <a:solidFill>
-            <a:srgbClr val="DA8B35"/>
+            <a:srgbClr val="E7F0F7"/>
           </a:solidFill>
-          <a:ln>
-            <a:noFill/>
+          <a:ln w="13970">
+            <a:solidFill>
+              <a:srgbClr val="E7F0F7"/>
+            </a:solidFill>
           </a:ln>
         </p:spPr>
         <p:style>
@@ -9674,22 +9634,22 @@
       </p:sp>
       <p:sp>
         <p:nvSpPr>
-          <p:cNvPr id="16" name="TextBox 15"/>
-          <p:cNvSpPr txBox="1"/>
-          <p:nvPr/>
-        </p:nvSpPr>
-        <p:spPr>
-          <a:xfrm>
-            <a:off x="1005840" y="4055363"/>
-            <a:ext cx="411480" cy="402336"/>
-          </a:xfrm>
-          <a:prstGeom prst="rect">
-            <a:avLst/>
-          </a:prstGeom>
-          <a:noFill/>
-        </p:spPr>
-        <p:txBody>
-          <a:bodyPr wrap="square" lIns="0" rIns="0" tIns="0" bIns="0" anchor="ctr">
+          <p:cNvPr id="14" name="TextBox 13"/>
+          <p:cNvSpPr txBox="1"/>
+          <p:nvPr/>
+        </p:nvSpPr>
+        <p:spPr>
+          <a:xfrm>
+            <a:off x="4407408" y="1828800"/>
+            <a:ext cx="1426464" cy="393192"/>
+          </a:xfrm>
+          <a:prstGeom prst="rect">
+            <a:avLst/>
+          </a:prstGeom>
+          <a:noFill/>
+        </p:spPr>
+        <p:txBody>
+          <a:bodyPr wrap="square" lIns="36576" rIns="36576" tIns="36576" bIns="36576" anchor="t">
             <a:spAutoFit/>
           </a:bodyPr>
           <a:lstStyle/>
@@ -9698,85 +9658,46 @@
               <a:spcAft>
                 <a:spcPts val="500"/>
               </a:spcAft>
-              <a:defRPr sz="1600" b="1">
-                <a:solidFill>
-                  <a:srgbClr val="FFFFFF"/>
-                </a:solidFill>
-                <a:latin typeface="Aptos"/>
-              </a:defRPr>
-            </a:pPr>
-            <a:r>
-              <a:t>3</a:t>
-            </a:r>
-          </a:p>
-        </p:txBody>
-      </p:sp>
-      <p:sp>
-        <p:nvSpPr>
-          <p:cNvPr id="17" name="TextBox 16"/>
-          <p:cNvSpPr txBox="1"/>
-          <p:nvPr/>
-        </p:nvSpPr>
-        <p:spPr>
-          <a:xfrm>
-            <a:off x="1600200" y="4041648"/>
-            <a:ext cx="1325880" cy="320040"/>
-          </a:xfrm>
-          <a:prstGeom prst="rect">
-            <a:avLst/>
-          </a:prstGeom>
-          <a:noFill/>
-        </p:spPr>
-        <p:txBody>
-          <a:bodyPr wrap="square" lIns="36576" rIns="36576" tIns="36576" bIns="36576" anchor="t">
-            <a:spAutoFit/>
-          </a:bodyPr>
-          <a:lstStyle/>
-          <a:p>
-            <a:pPr algn="l">
-              <a:spcAft>
-                <a:spcPts val="500"/>
-              </a:spcAft>
-              <a:defRPr sz="1800" b="1">
-                <a:solidFill>
-                  <a:srgbClr val="183452"/>
-                </a:solidFill>
-                <a:latin typeface="Aptos"/>
-              </a:defRPr>
-            </a:pPr>
-            <a:r>
-              <a:t>Decide</a:t>
-            </a:r>
-          </a:p>
-        </p:txBody>
-      </p:sp>
-      <p:sp>
-        <p:nvSpPr>
-          <p:cNvPr id="18" name="TextBox 17"/>
-          <p:cNvSpPr txBox="1"/>
-          <p:nvPr/>
-        </p:nvSpPr>
-        <p:spPr>
-          <a:xfrm>
-            <a:off x="2880360" y="4041648"/>
-            <a:ext cx="3657600" cy="512064"/>
-          </a:xfrm>
-          <a:prstGeom prst="rect">
-            <a:avLst/>
-          </a:prstGeom>
-          <a:noFill/>
-        </p:spPr>
-        <p:txBody>
-          <a:bodyPr wrap="square" lIns="36576" rIns="36576" tIns="36576" bIns="36576" anchor="t">
-            <a:spAutoFit/>
-          </a:bodyPr>
-          <a:lstStyle/>
-          <a:p>
-            <a:pPr algn="l">
-              <a:spcAft>
-                <a:spcPts val="500"/>
-              </a:spcAft>
-              <a:defRPr sz="1600" b="0">
+              <a:defRPr sz="2700" b="1">
+                <a:solidFill>
+                  <a:srgbClr val="DA8B35"/>
+                </a:solidFill>
+                <a:latin typeface="Aptos"/>
+              </a:defRPr>
+            </a:pPr>
+            <a:r>
+              <a:t>69</a:t>
+            </a:r>
+          </a:p>
+        </p:txBody>
+      </p:sp>
+      <p:sp>
+        <p:nvSpPr>
+          <p:cNvPr id="15" name="TextBox 14"/>
+          <p:cNvSpPr txBox="1"/>
+          <p:nvPr/>
+        </p:nvSpPr>
+        <p:spPr>
+          <a:xfrm>
+            <a:off x="4407408" y="2286000"/>
+            <a:ext cx="1426464" cy="384048"/>
+          </a:xfrm>
+          <a:prstGeom prst="rect">
+            <a:avLst/>
+          </a:prstGeom>
+          <a:noFill/>
+        </p:spPr>
+        <p:txBody>
+          <a:bodyPr wrap="square" lIns="36576" rIns="36576" tIns="36576" bIns="36576" anchor="t">
+            <a:spAutoFit/>
+          </a:bodyPr>
+          <a:lstStyle/>
+          <a:p>
+            <a:pPr algn="ctr">
+              <a:spcAft>
+                <a:spcPts val="500"/>
+              </a:spcAft>
+              <a:defRPr sz="1100" b="0">
                 <a:solidFill>
                   <a:srgbClr val="26313B"/>
                 </a:solidFill>
@@ -9784,31 +9705,47 @@
               </a:defRPr>
             </a:pPr>
             <a:r>
-              <a:t>Author or reviewer interprets the requirement</a:t>
-            </a:r>
-          </a:p>
-        </p:txBody>
-      </p:sp>
-      <p:sp>
-        <p:nvSpPr>
-          <p:cNvPr id="19" name="Rounded Rectangle 18"/>
+              <a:t>sections</a:t>
+            </a:r>
+          </a:p>
+          <a:p>
+            <a:pPr algn="ctr">
+              <a:spcAft>
+                <a:spcPts val="500"/>
+              </a:spcAft>
+              <a:defRPr sz="1100" b="0">
+                <a:solidFill>
+                  <a:srgbClr val="26313B"/>
+                </a:solidFill>
+                <a:latin typeface="Aptos"/>
+              </a:defRPr>
+            </a:pPr>
+            <a:r>
+              <a:t>represented</a:t>
+            </a:r>
+          </a:p>
+        </p:txBody>
+      </p:sp>
+      <p:sp>
+        <p:nvSpPr>
+          <p:cNvPr id="16" name="Rounded Rectangle 15"/>
           <p:cNvSpPr/>
           <p:nvPr/>
         </p:nvSpPr>
         <p:spPr>
           <a:xfrm>
-            <a:off x="7132320" y="1371600"/>
-            <a:ext cx="4069080" cy="2331720"/>
+            <a:off x="822960" y="3108960"/>
+            <a:ext cx="5084064" cy="1417320"/>
           </a:xfrm>
           <a:prstGeom prst="roundRect">
             <a:avLst/>
           </a:prstGeom>
           <a:solidFill>
-            <a:srgbClr val="FAEDEB"/>
+            <a:srgbClr val="E7F5F3"/>
           </a:solidFill>
           <a:ln w="13970">
             <a:solidFill>
-              <a:srgbClr val="FAEDEB"/>
+              <a:srgbClr val="D6E0E7"/>
             </a:solidFill>
           </a:ln>
         </p:spPr>
@@ -9836,62 +9773,25 @@
       </p:sp>
       <p:sp>
         <p:nvSpPr>
-          <p:cNvPr id="20" name="TextBox 19"/>
-          <p:cNvSpPr txBox="1"/>
-          <p:nvPr/>
-        </p:nvSpPr>
-        <p:spPr>
-          <a:xfrm>
-            <a:off x="7452360" y="1627632"/>
-            <a:ext cx="3429000" cy="384048"/>
-          </a:xfrm>
-          <a:prstGeom prst="rect">
-            <a:avLst/>
-          </a:prstGeom>
-          <a:noFill/>
-        </p:spPr>
-        <p:txBody>
-          <a:bodyPr wrap="square" lIns="36576" rIns="36576" tIns="36576" bIns="36576" anchor="t">
-            <a:spAutoFit/>
-          </a:bodyPr>
-          <a:lstStyle/>
-          <a:p>
-            <a:pPr algn="l">
-              <a:spcAft>
-                <a:spcPts val="500"/>
-              </a:spcAft>
-              <a:defRPr sz="2100" b="1">
-                <a:solidFill>
-                  <a:srgbClr val="A6413E"/>
-                </a:solidFill>
-                <a:latin typeface="Aptos"/>
-              </a:defRPr>
-            </a:pPr>
-            <a:r>
-              <a:t>Guardrails</a:t>
-            </a:r>
-          </a:p>
-        </p:txBody>
-      </p:sp>
-      <p:sp>
-        <p:nvSpPr>
-          <p:cNvPr id="21" name="Oval 20"/>
+          <p:cNvPr id="17" name="Rectangle 16"/>
           <p:cNvSpPr/>
           <p:nvPr/>
         </p:nvSpPr>
         <p:spPr>
           <a:xfrm>
-            <a:off x="7452360" y="2139696"/>
-            <a:ext cx="164592" cy="164592"/>
-          </a:xfrm>
-          <a:prstGeom prst="ellipse">
+            <a:off x="822960" y="3108960"/>
+            <a:ext cx="82296" cy="1417320"/>
+          </a:xfrm>
+          <a:prstGeom prst="rect">
             <a:avLst/>
           </a:prstGeom>
           <a:solidFill>
             <a:srgbClr val="1C8585"/>
           </a:solidFill>
           <a:ln>
-            <a:noFill/>
+            <a:solidFill>
+              <a:srgbClr val="1C8585"/>
+            </a:solidFill>
           </a:ln>
         </p:spPr>
         <p:style>
@@ -9918,50 +9818,14 @@
       </p:sp>
       <p:sp>
         <p:nvSpPr>
-          <p:cNvPr id="22" name="TextBox 21"/>
-          <p:cNvSpPr txBox="1"/>
-          <p:nvPr/>
-        </p:nvSpPr>
-        <p:spPr>
-          <a:xfrm>
-            <a:off x="7452360" y="2144268"/>
-            <a:ext cx="164592" cy="155448"/>
-          </a:xfrm>
-          <a:prstGeom prst="rect">
-            <a:avLst/>
-          </a:prstGeom>
-          <a:noFill/>
-        </p:spPr>
-        <p:txBody>
-          <a:bodyPr wrap="square" lIns="0" rIns="0" tIns="0" bIns="0" anchor="ctr">
-            <a:spAutoFit/>
-          </a:bodyPr>
-          <a:lstStyle/>
-          <a:p>
-            <a:pPr algn="ctr">
-              <a:spcAft>
-                <a:spcPts val="500"/>
-              </a:spcAft>
-              <a:defRPr sz="600" b="1">
-                <a:solidFill>
-                  <a:srgbClr val="FFFFFF"/>
-                </a:solidFill>
-                <a:latin typeface="Aptos"/>
-              </a:defRPr>
-            </a:pPr>
-          </a:p>
-        </p:txBody>
-      </p:sp>
-      <p:sp>
-        <p:nvSpPr>
-          <p:cNvPr id="23" name="TextBox 22"/>
-          <p:cNvSpPr txBox="1"/>
-          <p:nvPr/>
-        </p:nvSpPr>
-        <p:spPr>
-          <a:xfrm>
-            <a:off x="7744968" y="2103120"/>
-            <a:ext cx="3044952" cy="384048"/>
+          <p:cNvPr id="18" name="TextBox 17"/>
+          <p:cNvSpPr txBox="1"/>
+          <p:nvPr/>
+        </p:nvSpPr>
+        <p:spPr>
+          <a:xfrm>
+            <a:off x="1042416" y="3291840"/>
+            <a:ext cx="4690872" cy="347472"/>
           </a:xfrm>
           <a:prstGeom prst="rect">
             <a:avLst/>
@@ -9978,7 +9842,46 @@
               <a:spcAft>
                 <a:spcPts val="500"/>
               </a:spcAft>
-              <a:defRPr sz="1300" b="0">
+              <a:defRPr sz="1600" b="1">
+                <a:solidFill>
+                  <a:srgbClr val="183452"/>
+                </a:solidFill>
+                <a:latin typeface="Aptos"/>
+              </a:defRPr>
+            </a:pPr>
+            <a:r>
+              <a:t>Example ranked suggestion</a:t>
+            </a:r>
+          </a:p>
+        </p:txBody>
+      </p:sp>
+      <p:sp>
+        <p:nvSpPr>
+          <p:cNvPr id="19" name="TextBox 18"/>
+          <p:cNvSpPr txBox="1"/>
+          <p:nvPr/>
+        </p:nvSpPr>
+        <p:spPr>
+          <a:xfrm>
+            <a:off x="1042416" y="3721608"/>
+            <a:ext cx="4672583" cy="667512"/>
+          </a:xfrm>
+          <a:prstGeom prst="rect">
+            <a:avLst/>
+          </a:prstGeom>
+          <a:noFill/>
+        </p:spPr>
+        <p:txBody>
+          <a:bodyPr wrap="square" lIns="36576" rIns="36576" tIns="36576" bIns="36576" anchor="t">
+            <a:spAutoFit/>
+          </a:bodyPr>
+          <a:lstStyle/>
+          <a:p>
+            <a:pPr algn="l">
+              <a:spcAft>
+                <a:spcPts val="500"/>
+              </a:spcAft>
+              <a:defRPr sz="1400" b="0">
                 <a:solidFill>
                   <a:srgbClr val="26313B"/>
                 </a:solidFill>
@@ -9986,30 +9889,48 @@
               </a:defRPr>
             </a:pPr>
             <a:r>
-              <a:t>Never auto-reject a draft</a:t>
-            </a:r>
-          </a:p>
-        </p:txBody>
-      </p:sp>
-      <p:sp>
-        <p:nvSpPr>
-          <p:cNvPr id="24" name="Oval 23"/>
+              <a:t>Line 4727 · Section 14.2.1 · score 0.5433</a:t>
+            </a:r>
+          </a:p>
+          <a:p>
+            <a:pPr algn="l">
+              <a:spcAft>
+                <a:spcPts val="500"/>
+              </a:spcAft>
+              <a:defRPr sz="1400" b="0">
+                <a:solidFill>
+                  <a:srgbClr val="26313B"/>
+                </a:solidFill>
+                <a:latin typeface="Aptos"/>
+              </a:defRPr>
+            </a:pPr>
+            <a:r>
+              <a:t>“The endpoint SHOULD ignore all ICMP messages that fail validation.”</a:t>
+            </a:r>
+          </a:p>
+        </p:txBody>
+      </p:sp>
+      <p:sp>
+        <p:nvSpPr>
+          <p:cNvPr id="20" name="Rounded Rectangle 19"/>
           <p:cNvSpPr/>
           <p:nvPr/>
         </p:nvSpPr>
         <p:spPr>
           <a:xfrm>
-            <a:off x="7452360" y="2578608"/>
-            <a:ext cx="164592" cy="164592"/>
-          </a:xfrm>
-          <a:prstGeom prst="ellipse">
+            <a:off x="822960" y="4800600"/>
+            <a:ext cx="5084064" cy="960120"/>
+          </a:xfrm>
+          <a:prstGeom prst="roundRect">
             <a:avLst/>
           </a:prstGeom>
           <a:solidFill>
-            <a:srgbClr val="1C8585"/>
+            <a:srgbClr val="FBF2E3"/>
           </a:solidFill>
-          <a:ln>
-            <a:noFill/>
+          <a:ln w="13970">
+            <a:solidFill>
+              <a:srgbClr val="FBF2E3"/>
+            </a:solidFill>
           </a:ln>
         </p:spPr>
         <p:style>
@@ -10036,401 +9957,172 @@
       </p:sp>
       <p:sp>
         <p:nvSpPr>
-          <p:cNvPr id="25" name="TextBox 24"/>
-          <p:cNvSpPr txBox="1"/>
-          <p:nvPr/>
-        </p:nvSpPr>
-        <p:spPr>
-          <a:xfrm>
-            <a:off x="7452360" y="2583179"/>
-            <a:ext cx="164592" cy="155448"/>
-          </a:xfrm>
-          <a:prstGeom prst="rect">
-            <a:avLst/>
-          </a:prstGeom>
-          <a:noFill/>
-        </p:spPr>
-        <p:txBody>
-          <a:bodyPr wrap="square" lIns="0" rIns="0" tIns="0" bIns="0" anchor="ctr">
-            <a:spAutoFit/>
-          </a:bodyPr>
-          <a:lstStyle/>
-          <a:p>
-            <a:pPr algn="ctr">
-              <a:spcAft>
-                <a:spcPts val="500"/>
-              </a:spcAft>
-              <a:defRPr sz="600" b="1">
-                <a:solidFill>
-                  <a:srgbClr val="FFFFFF"/>
-                </a:solidFill>
-                <a:latin typeface="Aptos"/>
-              </a:defRPr>
-            </a:pPr>
-          </a:p>
-        </p:txBody>
-      </p:sp>
+          <p:cNvPr id="21" name="TextBox 20"/>
+          <p:cNvSpPr txBox="1"/>
+          <p:nvPr/>
+        </p:nvSpPr>
+        <p:spPr>
+          <a:xfrm>
+            <a:off x="1024128" y="4965192"/>
+            <a:ext cx="4681728" cy="621792"/>
+          </a:xfrm>
+          <a:prstGeom prst="rect">
+            <a:avLst/>
+          </a:prstGeom>
+          <a:noFill/>
+        </p:spPr>
+        <p:txBody>
+          <a:bodyPr wrap="square" lIns="36576" rIns="36576" tIns="36576" bIns="36576" anchor="t">
+            <a:spAutoFit/>
+          </a:bodyPr>
+          <a:lstStyle/>
+          <a:p>
+            <a:pPr algn="l">
+              <a:spcAft>
+                <a:spcPts val="500"/>
+              </a:spcAft>
+              <a:defRPr sz="1300" b="0">
+                <a:solidFill>
+                  <a:srgbClr val="26313B"/>
+                </a:solidFill>
+                <a:latin typeface="Aptos"/>
+              </a:defRPr>
+            </a:pPr>
+            <a:r>
+              <a:t>Scores rank clauses for review; they are not calibrated probabilities or ambiguity verdicts. This capture also had a scikit-learn artifact/runtime version warning.</a:t>
+            </a:r>
+          </a:p>
+        </p:txBody>
+      </p:sp>
+      <p:sp>
+        <p:nvSpPr>
+          <p:cNvPr id="22" name="TextBox 21"/>
+          <p:cNvSpPr txBox="1"/>
+          <p:nvPr/>
+        </p:nvSpPr>
+        <p:spPr>
+          <a:xfrm>
+            <a:off x="6720840" y="1152144"/>
+            <a:ext cx="4892040" cy="201168"/>
+          </a:xfrm>
+          <a:prstGeom prst="rect">
+            <a:avLst/>
+          </a:prstGeom>
+          <a:noFill/>
+        </p:spPr>
+        <p:txBody>
+          <a:bodyPr wrap="square" lIns="36576" rIns="36576" tIns="36576" bIns="36576" anchor="t">
+            <a:spAutoFit/>
+          </a:bodyPr>
+          <a:lstStyle/>
+          <a:p>
+            <a:pPr algn="l">
+              <a:spcAft>
+                <a:spcPts val="500"/>
+              </a:spcAft>
+              <a:defRPr sz="1100" b="1">
+                <a:solidFill>
+                  <a:srgbClr val="1C8585"/>
+                </a:solidFill>
+                <a:latin typeface="Aptos"/>
+              </a:defRPr>
+            </a:pPr>
+            <a:r>
+              <a:t>Overview · RFC 9000</a:t>
+            </a:r>
+          </a:p>
+        </p:txBody>
+      </p:sp>
+      <p:pic>
+        <p:nvPicPr>
+          <p:cNvPr id="23" name="Picture 22" descr="gui_rfc9000_overview.png"/>
+          <p:cNvPicPr>
+            <a:picLocks noChangeAspect="1"/>
+          </p:cNvPicPr>
+          <p:nvPr/>
+        </p:nvPicPr>
+        <p:blipFill>
+          <a:blip r:embed="rId2"/>
+          <a:stretch>
+            <a:fillRect/>
+          </a:stretch>
+        </p:blipFill>
+        <p:spPr>
+          <a:xfrm>
+            <a:off x="6720840" y="1389888"/>
+            <a:ext cx="4800600" cy="2226478"/>
+          </a:xfrm>
+          <a:prstGeom prst="rect">
+            <a:avLst/>
+          </a:prstGeom>
+        </p:spPr>
+      </p:pic>
+      <p:sp>
+        <p:nvSpPr>
+          <p:cNvPr id="24" name="TextBox 23"/>
+          <p:cNvSpPr txBox="1"/>
+          <p:nvPr/>
+        </p:nvSpPr>
+        <p:spPr>
+          <a:xfrm>
+            <a:off x="6720840" y="3730752"/>
+            <a:ext cx="4892040" cy="201168"/>
+          </a:xfrm>
+          <a:prstGeom prst="rect">
+            <a:avLst/>
+          </a:prstGeom>
+          <a:noFill/>
+        </p:spPr>
+        <p:txBody>
+          <a:bodyPr wrap="square" lIns="36576" rIns="36576" tIns="36576" bIns="36576" anchor="t">
+            <a:spAutoFit/>
+          </a:bodyPr>
+          <a:lstStyle/>
+          <a:p>
+            <a:pPr algn="l">
+              <a:spcAft>
+                <a:spcPts val="500"/>
+              </a:spcAft>
+              <a:defRPr sz="1100" b="1">
+                <a:solidFill>
+                  <a:srgbClr val="1C8585"/>
+                </a:solidFill>
+                <a:latin typeface="Aptos"/>
+              </a:defRPr>
+            </a:pPr>
+            <a:r>
+              <a:t>Filtered suggestion · one of 112 flagged clauses</a:t>
+            </a:r>
+          </a:p>
+        </p:txBody>
+      </p:sp>
+      <p:pic>
+        <p:nvPicPr>
+          <p:cNvPr id="25" name="Picture 24" descr="gui_rfc9000_filtered_results.png"/>
+          <p:cNvPicPr>
+            <a:picLocks noChangeAspect="1"/>
+          </p:cNvPicPr>
+          <p:nvPr/>
+        </p:nvPicPr>
+        <p:blipFill>
+          <a:blip r:embed="rId3"/>
+          <a:stretch>
+            <a:fillRect/>
+          </a:stretch>
+        </p:blipFill>
+        <p:spPr>
+          <a:xfrm>
+            <a:off x="6720840" y="3968496"/>
+            <a:ext cx="4800600" cy="2226478"/>
+          </a:xfrm>
+          <a:prstGeom prst="rect">
+            <a:avLst/>
+          </a:prstGeom>
+        </p:spPr>
+      </p:pic>
       <p:sp>
         <p:nvSpPr>
           <p:cNvPr id="26" name="TextBox 25"/>
-          <p:cNvSpPr txBox="1"/>
-          <p:nvPr/>
-        </p:nvSpPr>
-        <p:spPr>
-          <a:xfrm>
-            <a:off x="7744968" y="2542032"/>
-            <a:ext cx="3044952" cy="384048"/>
-          </a:xfrm>
-          <a:prstGeom prst="rect">
-            <a:avLst/>
-          </a:prstGeom>
-          <a:noFill/>
-        </p:spPr>
-        <p:txBody>
-          <a:bodyPr wrap="square" lIns="36576" rIns="36576" tIns="36576" bIns="36576" anchor="t">
-            <a:spAutoFit/>
-          </a:bodyPr>
-          <a:lstStyle/>
-          <a:p>
-            <a:pPr algn="l">
-              <a:spcAft>
-                <a:spcPts val="500"/>
-              </a:spcAft>
-              <a:defRPr sz="1300" b="0">
-                <a:solidFill>
-                  <a:srgbClr val="26313B"/>
-                </a:solidFill>
-                <a:latin typeface="Aptos"/>
-              </a:defRPr>
-            </a:pPr>
-            <a:r>
-              <a:t>Expose uncertainty and provenance</a:t>
-            </a:r>
-          </a:p>
-        </p:txBody>
-      </p:sp>
-      <p:sp>
-        <p:nvSpPr>
-          <p:cNvPr id="27" name="Oval 26"/>
-          <p:cNvSpPr/>
-          <p:nvPr/>
-        </p:nvSpPr>
-        <p:spPr>
-          <a:xfrm>
-            <a:off x="7452360" y="3017520"/>
-            <a:ext cx="164592" cy="164592"/>
-          </a:xfrm>
-          <a:prstGeom prst="ellipse">
-            <a:avLst/>
-          </a:prstGeom>
-          <a:solidFill>
-            <a:srgbClr val="1C8585"/>
-          </a:solidFill>
-          <a:ln>
-            <a:noFill/>
-          </a:ln>
-        </p:spPr>
-        <p:style>
-          <a:lnRef idx="1">
-            <a:schemeClr val="accent1"/>
-          </a:lnRef>
-          <a:fillRef idx="3">
-            <a:schemeClr val="accent1"/>
-          </a:fillRef>
-          <a:effectRef idx="2">
-            <a:schemeClr val="accent1"/>
-          </a:effectRef>
-          <a:fontRef idx="minor">
-            <a:schemeClr val="lt1"/>
-          </a:fontRef>
-        </p:style>
-        <p:txBody>
-          <a:bodyPr rtlCol="0" anchor="ctr"/>
-          <a:lstStyle/>
-          <a:p>
-            <a:pPr algn="ctr"/>
-          </a:p>
-        </p:txBody>
-      </p:sp>
-      <p:sp>
-        <p:nvSpPr>
-          <p:cNvPr id="28" name="TextBox 27"/>
-          <p:cNvSpPr txBox="1"/>
-          <p:nvPr/>
-        </p:nvSpPr>
-        <p:spPr>
-          <a:xfrm>
-            <a:off x="7452360" y="3022091"/>
-            <a:ext cx="164592" cy="155448"/>
-          </a:xfrm>
-          <a:prstGeom prst="rect">
-            <a:avLst/>
-          </a:prstGeom>
-          <a:noFill/>
-        </p:spPr>
-        <p:txBody>
-          <a:bodyPr wrap="square" lIns="0" rIns="0" tIns="0" bIns="0" anchor="ctr">
-            <a:spAutoFit/>
-          </a:bodyPr>
-          <a:lstStyle/>
-          <a:p>
-            <a:pPr algn="ctr">
-              <a:spcAft>
-                <a:spcPts val="500"/>
-              </a:spcAft>
-              <a:defRPr sz="600" b="1">
-                <a:solidFill>
-                  <a:srgbClr val="FFFFFF"/>
-                </a:solidFill>
-                <a:latin typeface="Aptos"/>
-              </a:defRPr>
-            </a:pPr>
-          </a:p>
-        </p:txBody>
-      </p:sp>
-      <p:sp>
-        <p:nvSpPr>
-          <p:cNvPr id="29" name="TextBox 28"/>
-          <p:cNvSpPr txBox="1"/>
-          <p:nvPr/>
-        </p:nvSpPr>
-        <p:spPr>
-          <a:xfrm>
-            <a:off x="7744968" y="2980944"/>
-            <a:ext cx="3044952" cy="384048"/>
-          </a:xfrm>
-          <a:prstGeom prst="rect">
-            <a:avLst/>
-          </a:prstGeom>
-          <a:noFill/>
-        </p:spPr>
-        <p:txBody>
-          <a:bodyPr wrap="square" lIns="36576" rIns="36576" tIns="36576" bIns="36576" anchor="t">
-            <a:spAutoFit/>
-          </a:bodyPr>
-          <a:lstStyle/>
-          <a:p>
-            <a:pPr algn="l">
-              <a:spcAft>
-                <a:spcPts val="500"/>
-              </a:spcAft>
-              <a:defRPr sz="1300" b="0">
-                <a:solidFill>
-                  <a:srgbClr val="26313B"/>
-                </a:solidFill>
-                <a:latin typeface="Aptos"/>
-              </a:defRPr>
-            </a:pPr>
-            <a:r>
-              <a:t>Do not treat generated explanations as proof</a:t>
-            </a:r>
-          </a:p>
-        </p:txBody>
-      </p:sp>
-      <p:sp>
-        <p:nvSpPr>
-          <p:cNvPr id="30" name="Rounded Rectangle 29"/>
-          <p:cNvSpPr/>
-          <p:nvPr/>
-        </p:nvSpPr>
-        <p:spPr>
-          <a:xfrm>
-            <a:off x="7132320" y="3877056"/>
-            <a:ext cx="4069080" cy="1207008"/>
-          </a:xfrm>
-          <a:prstGeom prst="roundRect">
-            <a:avLst/>
-          </a:prstGeom>
-          <a:solidFill>
-            <a:srgbClr val="E7F5F3"/>
-          </a:solidFill>
-          <a:ln w="13970">
-            <a:solidFill>
-              <a:srgbClr val="E7F5F3"/>
-            </a:solidFill>
-          </a:ln>
-        </p:spPr>
-        <p:style>
-          <a:lnRef idx="1">
-            <a:schemeClr val="accent1"/>
-          </a:lnRef>
-          <a:fillRef idx="3">
-            <a:schemeClr val="accent1"/>
-          </a:fillRef>
-          <a:effectRef idx="2">
-            <a:schemeClr val="accent1"/>
-          </a:effectRef>
-          <a:fontRef idx="minor">
-            <a:schemeClr val="lt1"/>
-          </a:fontRef>
-        </p:style>
-        <p:txBody>
-          <a:bodyPr rtlCol="0" anchor="ctr"/>
-          <a:lstStyle/>
-          <a:p>
-            <a:pPr algn="ctr"/>
-          </a:p>
-        </p:txBody>
-      </p:sp>
-      <p:sp>
-        <p:nvSpPr>
-          <p:cNvPr id="31" name="TextBox 30"/>
-          <p:cNvSpPr txBox="1"/>
-          <p:nvPr/>
-        </p:nvSpPr>
-        <p:spPr>
-          <a:xfrm>
-            <a:off x="7388352" y="4023360"/>
-            <a:ext cx="3566160" cy="237744"/>
-          </a:xfrm>
-          <a:prstGeom prst="rect">
-            <a:avLst/>
-          </a:prstGeom>
-          <a:noFill/>
-        </p:spPr>
-        <p:txBody>
-          <a:bodyPr wrap="square" lIns="36576" rIns="36576" tIns="36576" bIns="36576" anchor="t">
-            <a:spAutoFit/>
-          </a:bodyPr>
-          <a:lstStyle/>
-          <a:p>
-            <a:pPr algn="l">
-              <a:spcAft>
-                <a:spcPts val="500"/>
-              </a:spcAft>
-              <a:defRPr sz="1000" b="1">
-                <a:solidFill>
-                  <a:srgbClr val="1C8585"/>
-                </a:solidFill>
-                <a:latin typeface="Aptos"/>
-              </a:defRPr>
-            </a:pPr>
-            <a:r>
-              <a:t>ILLUSTRATIVE MODEL OUTPUT</a:t>
-            </a:r>
-          </a:p>
-        </p:txBody>
-      </p:sp>
-      <p:sp>
-        <p:nvSpPr>
-          <p:cNvPr id="32" name="TextBox 31"/>
-          <p:cNvSpPr txBox="1"/>
-          <p:nvPr/>
-        </p:nvSpPr>
-        <p:spPr>
-          <a:xfrm>
-            <a:off x="7388352" y="4343400"/>
-            <a:ext cx="566928" cy="310896"/>
-          </a:xfrm>
-          <a:prstGeom prst="rect">
-            <a:avLst/>
-          </a:prstGeom>
-          <a:noFill/>
-        </p:spPr>
-        <p:txBody>
-          <a:bodyPr wrap="square" lIns="36576" rIns="36576" tIns="36576" bIns="36576" anchor="t">
-            <a:spAutoFit/>
-          </a:bodyPr>
-          <a:lstStyle/>
-          <a:p>
-            <a:pPr algn="l">
-              <a:spcAft>
-                <a:spcPts val="500"/>
-              </a:spcAft>
-              <a:defRPr sz="1700" b="1">
-                <a:solidFill>
-                  <a:srgbClr val="1C8585"/>
-                </a:solidFill>
-                <a:latin typeface="Aptos"/>
-              </a:defRPr>
-            </a:pPr>
-            <a:r>
-              <a:t>YES</a:t>
-            </a:r>
-          </a:p>
-        </p:txBody>
-      </p:sp>
-      <p:sp>
-        <p:nvSpPr>
-          <p:cNvPr id="33" name="TextBox 32"/>
-          <p:cNvSpPr txBox="1"/>
-          <p:nvPr/>
-        </p:nvSpPr>
-        <p:spPr>
-          <a:xfrm>
-            <a:off x="8028431" y="4288536"/>
-            <a:ext cx="2907792" cy="603504"/>
-          </a:xfrm>
-          <a:prstGeom prst="rect">
-            <a:avLst/>
-          </a:prstGeom>
-          <a:noFill/>
-        </p:spPr>
-        <p:txBody>
-          <a:bodyPr wrap="square" lIns="36576" rIns="36576" tIns="36576" bIns="36576" anchor="t">
-            <a:spAutoFit/>
-          </a:bodyPr>
-          <a:lstStyle/>
-          <a:p>
-            <a:pPr algn="l">
-              <a:spcAft>
-                <a:spcPts val="500"/>
-              </a:spcAft>
-              <a:defRPr sz="1300" b="0">
-                <a:solidFill>
-                  <a:srgbClr val="26313B"/>
-                </a:solidFill>
-                <a:latin typeface="Aptos"/>
-              </a:defRPr>
-            </a:pPr>
-            <a:r>
-              <a:t>“When appropriate” leaves the retry condition open.</a:t>
-            </a:r>
-          </a:p>
-        </p:txBody>
-      </p:sp>
-      <p:sp>
-        <p:nvSpPr>
-          <p:cNvPr id="34" name="TextBox 33"/>
-          <p:cNvSpPr txBox="1"/>
-          <p:nvPr/>
-        </p:nvSpPr>
-        <p:spPr>
-          <a:xfrm>
-            <a:off x="914400" y="5394960"/>
-            <a:ext cx="10241280" cy="484632"/>
-          </a:xfrm>
-          <a:prstGeom prst="rect">
-            <a:avLst/>
-          </a:prstGeom>
-          <a:noFill/>
-        </p:spPr>
-        <p:txBody>
-          <a:bodyPr wrap="square" lIns="36576" rIns="36576" tIns="36576" bIns="36576" anchor="t">
-            <a:spAutoFit/>
-          </a:bodyPr>
-          <a:lstStyle/>
-          <a:p>
-            <a:pPr algn="ctr">
-              <a:spcAft>
-                <a:spcPts val="500"/>
-              </a:spcAft>
-              <a:defRPr sz="1800" b="1">
-                <a:solidFill>
-                  <a:srgbClr val="183452"/>
-                </a:solidFill>
-                <a:latin typeface="Aptos"/>
-              </a:defRPr>
-            </a:pPr>
-            <a:r>
-              <a:t>A false flag costs reviewer time; a missed flag can create false reassurance.</a:t>
-            </a:r>
-          </a:p>
-        </p:txBody>
-      </p:sp>
-      <p:sp>
-        <p:nvSpPr>
-          <p:cNvPr id="35" name="TextBox 34"/>
           <p:cNvSpPr txBox="1"/>
           <p:nvPr/>
         </p:nvSpPr>
@@ -10462,14 +10154,14 @@
               </a:defRPr>
             </a:pPr>
             <a:r>
-              <a:t>Source: paper/main.tex, Ethical and Practical Considerations.</a:t>
-            </a:r>
-          </a:p>
-        </p:txBody>
-      </p:sp>
-      <p:sp>
-        <p:nvSpPr>
-          <p:cNvPr id="36" name="TextBox 35"/>
+              <a:t>GUI screenshots: local scan of corpus/raw/rfcs/RFC9000.txt; model scores are screening ranks.</a:t>
+            </a:r>
+          </a:p>
+        </p:txBody>
+      </p:sp>
+      <p:sp>
+        <p:nvSpPr>
+          <p:cNvPr id="27" name="TextBox 26"/>
           <p:cNvSpPr txBox="1"/>
           <p:nvPr/>
         </p:nvSpPr>
@@ -11089,7 +10781,7 @@
               </a:defRPr>
             </a:pPr>
             <a:r>
-              <a:t>Retrain ML on the same frozen labels; repeat finalists across seeds.</a:t>
+              <a:t>Retrain classical and Qwen/hybrid on common labels and folds; repeat finalists across seeds.</a:t>
             </a:r>
           </a:p>
         </p:txBody>
@@ -16964,7 +16656,7 @@
               </a:defRPr>
             </a:pPr>
             <a:r>
-              <a:t>2,125 clauses · 9 families</a:t>
+              <a:t>2,143 clauses · 9 families</a:t>
             </a:r>
           </a:p>
         </p:txBody>
@@ -17003,7 +16695,7 @@
               </a:defRPr>
             </a:pPr>
             <a:r>
-              <a:t>136 positives · prevalence 6.40%</a:t>
+              <a:t>138 positives · prevalence 6.44%</a:t>
             </a:r>
           </a:p>
         </p:txBody>
@@ -17042,7 +16734,7 @@
               </a:defRPr>
             </a:pPr>
             <a:r>
-              <a:t>Different label snapshots and eligibility rules: these cohorts are not one shared leaderboard.</a:t>
+              <a:t>Different label snapshots and eligibility rules: only the three latest DeBERTa methods share one cohort.</a:t>
             </a:r>
           </a:p>
         </p:txBody>
@@ -17081,7 +16773,7 @@
               </a:defRPr>
             </a:pPr>
             <a:r>
-              <a:t>Source: README.md; paper/main.tex. Cohort metrics are study-specific.</a:t>
+              <a:t>Source: paper/main.tex; study-specific cohorts and label snapshots.</a:t>
             </a:r>
           </a:p>
         </p:txBody>

</xml_diff>